<commit_message>
Añade infografías de apoyo al Tema 1 (Acceso a Datos)
Incorpora 10 diagramas visuales en los 8 apartados de teoría del
Tema 1 (starters de Maven, capas AD/PSP, entidad vs DTO, piezas de
JDBC, contexto de persistencia, paginación, explosión combinatoria
de filtros, las tres vías de consulta y GROUP BY) y actualiza las
diapositivas correspondientes.
</commit_message>
<xml_diff>
--- a/docs/tema1/diapositivas/conectores-y-protocolos.pptx
+++ b/docs/tema1/diapositivas/conectores-y-protocolos.pptx
@@ -4109,8 +4109,8 @@
         </p:nvSpPr>
         <p:spPr>
           <a:xfrm>
-            <a:off x="548640" y="2148840"/>
-            <a:ext cx="11091672" cy="1554480"/>
+            <a:off x="628884" y="1230863"/>
+            <a:ext cx="3803158" cy="2314769"/>
           </a:xfrm>
           <a:prstGeom prst="rect">
             <a:avLst/>
@@ -4126,7 +4126,7 @@
               <a:buNone/>
             </a:pPr>
             <a:r>
-              <a:rPr lang="en-US" sz="2100" dirty="0">
+              <a:rPr lang="en-US" dirty="0">
                 <a:solidFill>
                   <a:srgbClr val="212121"/>
                 </a:solidFill>
@@ -4136,7 +4136,7 @@
               </a:rPr>
               <a:t>Un gestor embebido vive dentro de tu propio proceso: no hay nada que instalar ni levantar aparte, arranca y desaparece con tu aplicación. Es rápido de poner en marcha, pero normalmente no está pensado para que varias aplicaciones distintas lo usen a la vez.</a:t>
             </a:r>
-            <a:endParaRPr lang="en-US" sz="2100" dirty="0"/>
+            <a:endParaRPr lang="en-US" dirty="0"/>
           </a:p>
         </p:txBody>
       </p:sp>
@@ -4148,8 +4148,8 @@
         </p:nvSpPr>
         <p:spPr>
           <a:xfrm>
-            <a:off x="548640" y="4114800"/>
-            <a:ext cx="11091672" cy="1554480"/>
+            <a:off x="628884" y="3688608"/>
+            <a:ext cx="3803158" cy="2785344"/>
           </a:xfrm>
           <a:prstGeom prst="rect">
             <a:avLst/>
@@ -4165,7 +4165,7 @@
               <a:buNone/>
             </a:pPr>
             <a:r>
-              <a:rPr lang="en-US" sz="2100" dirty="0">
+              <a:rPr lang="en-US" dirty="0">
                 <a:solidFill>
                   <a:srgbClr val="212121"/>
                 </a:solidFill>
@@ -4175,10 +4175,41 @@
               </a:rPr>
               <a:t>Un gestor independiente corre como su propio servicio, escuchando en un puerto de red, y puede atender a muchos clientes al mismo tiempo. Es el mismo concepto de IP/puerto del apartado 1: un contenedor de PostgreSQL, separado de tu aplicación, al que te conectas por IP/puerto.</a:t>
             </a:r>
-            <a:endParaRPr lang="en-US" sz="2100" dirty="0"/>
-          </a:p>
-        </p:txBody>
-      </p:sp>
+            <a:endParaRPr lang="en-US" dirty="0"/>
+          </a:p>
+        </p:txBody>
+      </p:sp>
+      <p:pic>
+        <p:nvPicPr>
+          <p:cNvPr id="8" name="Imagen 7">
+            <a:extLst>
+              <a:ext uri="{FF2B5EF4-FFF2-40B4-BE49-F238E27FC236}">
+                <a16:creationId xmlns:a16="http://schemas.microsoft.com/office/drawing/2014/main" id="{DC18964C-1833-F775-E818-ACB99111B432}"/>
+              </a:ext>
+            </a:extLst>
+          </p:cNvPr>
+          <p:cNvPicPr>
+            <a:picLocks noChangeAspect="1"/>
+          </p:cNvPicPr>
+          <p:nvPr/>
+        </p:nvPicPr>
+        <p:blipFill>
+          <a:blip r:embed="rId3"/>
+          <a:srcRect l="3789" t="11333" r="2815" b="12381"/>
+          <a:stretch>
+            <a:fillRect/>
+          </a:stretch>
+        </p:blipFill>
+        <p:spPr>
+          <a:xfrm>
+            <a:off x="4480000" y="1626295"/>
+            <a:ext cx="7343192" cy="3998602"/>
+          </a:xfrm>
+          <a:prstGeom prst="rect">
+            <a:avLst/>
+          </a:prstGeom>
+        </p:spPr>
+      </p:pic>
     </p:spTree>
   </p:cSld>
   <p:clrMapOvr>

</xml_diff>